<commit_message>
Lab meeting 10/22 deck: drop the false-alarm budget, clarify the inference slide
Co-Authored-By: Claude Opus 5.5 <noreply@anthropic.com>
Claude-Session: https://claude.ai/code/session_017rMsJrfJb6LTfE8bFvgHeu
</commit_message>
<xml_diff>
--- a/docs/presentation/lab_meeting_10_22_demo.pptx
+++ b/docs/presentation/lab_meeting_10_22_demo.pptx
@@ -683,7 +683,7 @@
           <a:p>
             <a:r>
               <a:rPr lang="en-US" dirty="0"/>
-              <a:t>An episode is a run of consecutive eating windows (8 s). With pauses up to 32 s merged: 92.8% detected and 1.7 false episodes/h (default), 82.9% and 1.2/h (budget). Measured in meal sessions, not free living.</a:t>
+              <a:t>An episode is a run of consecutive eating windows (8 s). With pauses up to 32 s merged: 92.8% detected, 1.7 false episodes per hour. Measured in meal sessions, not free living.</a:t>
             </a:r>
             <a:endParaRPr lang="en-US" dirty="0"/>
           </a:p>
@@ -771,7 +771,7 @@
           <a:p>
             <a:r>
               <a:rPr lang="en-US" dirty="0"/>
-              <a:t>The 8 s second episode is a stray single window; --min-episode 16 would drop it. Open question: drop single-window episodes by default?</a:t>
+              <a:t>The 8 s second episode is a single stray window three minutes after the meal; a minimum episode length (e.g. 16 s) would drop it.</a:t>
             </a:r>
             <a:endParaRPr lang="en-US" dirty="0"/>
           </a:p>
@@ -1988,6 +1988,30 @@
           </a:p>
         </p:txBody>
       </p:sp>
+      <p:pic>
+        <p:nvPicPr>
+          <p:cNvPr id="3" name="Image 0" descr="Confusion matrix: 3,009 eating windows detected, 512 missed, 516 false alarms, 5,096 correct non-eating">    </p:cNvPr>
+          <p:cNvPicPr>
+            <a:picLocks noChangeAspect="1"/>
+          </p:cNvPicPr>
+          <p:nvPr/>
+        </p:nvPicPr>
+        <p:blipFill>
+          <a:blip r:embed="rId1"/>
+          <a:stretch>
+            <a:fillRect/>
+          </a:stretch>
+        </p:blipFill>
+        <p:spPr>
+          <a:xfrm>
+            <a:off x="411480" y="1005840"/>
+            <a:ext cx="3429000" cy="3566160"/>
+          </a:xfrm>
+          <a:prstGeom prst="rect">
+            <a:avLst/>
+          </a:prstGeom>
+        </p:spPr>
+      </p:pic>
       <p:graphicFrame>
         <p:nvGraphicFramePr>
           <p:cNvPr id="4" name="Table 0"/>
@@ -2003,19 +2027,18 @@
           </p:nvPr>
         </p:nvGraphicFramePr>
         <p:xfrm>
-          <a:off x="411480" y="1143000"/>
-          <a:ext cx="8321040" cy="914400"/>
+          <a:off x="4114800" y="1097280"/>
+          <a:ext cx="4617720" cy="914400"/>
         </p:xfrm>
         <a:graphic>
           <a:graphicData uri="http://schemas.openxmlformats.org/drawingml/2006/table">
             <a:tbl>
               <a:tblPr/>
               <a:tblGrid>
-                <a:gridCol w="3931920"/>
-                <a:gridCol w="2194560"/>
-                <a:gridCol w="2194560"/>
+                <a:gridCol w="3337560"/>
+                <a:gridCol w="1280160"/>
               </a:tblGrid>
-              <a:tr h="384048">
+              <a:tr h="365760">
                 <a:tc>
                   <a:txBody>
                     <a:bodyPr/>
@@ -2024,6 +2047,17 @@
                       <a:pPr indent="0" marL="0">
                         <a:buNone/>
                       </a:pPr>
+                      <a:r>
+                        <a:rPr lang="en-US" sz="1400" b="1" dirty="0">
+                          <a:solidFill>
+                            <a:schemeClr val="tx1"/>
+                          </a:solidFill>
+                          <a:latin typeface="Arial" pitchFamily="34" charset="0"/>
+                          <a:ea typeface="Arial" pitchFamily="34" charset="-122"/>
+                          <a:cs typeface="Arial" pitchFamily="34" charset="-120"/>
+                        </a:rPr>
+                        <a:t>Per eating episode</a:t>
+                      </a:r>
                       <a:endParaRPr lang="en-US" sz="1400" dirty="0">
                         <a:latin typeface="Arial" charset="0"/>
                         <a:ea typeface="Arial" charset="0"/>
@@ -2090,7 +2124,7 @@
                           <a:ea typeface="Arial" pitchFamily="34" charset="-122"/>
                           <a:cs typeface="Arial" pitchFamily="34" charset="-120"/>
                         </a:rPr>
-                        <a:t>Default threshold</a:t>
+                        <a:t>Result</a:t>
                       </a:r>
                       <a:endParaRPr lang="en-US" sz="1400" dirty="0">
                         <a:latin typeface="Arial" charset="0"/>
@@ -2141,76 +2175,8 @@
                     </a:solidFill>
                   </a:tcPr>
                 </a:tc>
-                <a:tc>
-                  <a:txBody>
-                    <a:bodyPr/>
-                    <a:lstStyle/>
-                    <a:p>
-                      <a:pPr indent="0" marL="0">
-                        <a:buNone/>
-                      </a:pPr>
-                      <a:r>
-                        <a:rPr lang="en-US" sz="1400" b="1" dirty="0">
-                          <a:solidFill>
-                            <a:schemeClr val="tx1"/>
-                          </a:solidFill>
-                          <a:latin typeface="Arial" pitchFamily="34" charset="0"/>
-                          <a:ea typeface="Arial" pitchFamily="34" charset="-122"/>
-                          <a:cs typeface="Arial" pitchFamily="34" charset="-120"/>
-                        </a:rPr>
-                        <a:t>False-alarm budget</a:t>
-                      </a:r>
-                      <a:endParaRPr lang="en-US" sz="1400" dirty="0">
-                        <a:latin typeface="Arial" charset="0"/>
-                        <a:ea typeface="Arial" charset="0"/>
-                        <a:cs typeface="Arial" charset="0"/>
-                      </a:endParaRPr>
-                    </a:p>
-                  </a:txBody>
-                  <a:tcPr marL="54864" marR="54864" marT="54864" marB="54864" anchor="ctr">
-                    <a:lnL w="9525" cap="flat" cmpd="sng" algn="ctr">
-                      <a:solidFill>
-                        <a:srgbClr val="BFBFBF"/>
-                      </a:solidFill>
-                      <a:prstDash val="solid"/>
-                      <a:round/>
-                      <a:headEnd type="none" w="med" len="med"/>
-                      <a:tailEnd type="none" w="med" len="med"/>
-                    </a:lnL>
-                    <a:lnR w="9525" cap="flat" cmpd="sng" algn="ctr">
-                      <a:solidFill>
-                        <a:srgbClr val="BFBFBF"/>
-                      </a:solidFill>
-                      <a:prstDash val="solid"/>
-                      <a:round/>
-                      <a:headEnd type="none" w="med" len="med"/>
-                      <a:tailEnd type="none" w="med" len="med"/>
-                    </a:lnR>
-                    <a:lnT w="9525" cap="flat" cmpd="sng" algn="ctr">
-                      <a:solidFill>
-                        <a:srgbClr val="BFBFBF"/>
-                      </a:solidFill>
-                      <a:prstDash val="solid"/>
-                      <a:round/>
-                      <a:headEnd type="none" w="med" len="med"/>
-                      <a:tailEnd type="none" w="med" len="med"/>
-                    </a:lnT>
-                    <a:lnB w="9525" cap="flat" cmpd="sng" algn="ctr">
-                      <a:solidFill>
-                        <a:srgbClr val="BFBFBF"/>
-                      </a:solidFill>
-                      <a:prstDash val="solid"/>
-                      <a:round/>
-                      <a:headEnd type="none" w="med" len="med"/>
-                      <a:tailEnd type="none" w="med" len="med"/>
-                    </a:lnB>
-                    <a:solidFill>
-                      <a:srgbClr val="F2F2F2"/>
-                    </a:solidFill>
-                  </a:tcPr>
-                </a:tc>
               </a:tr>
-              <a:tr h="384048">
+              <a:tr h="365760">
                 <a:tc>
                   <a:txBody>
                     <a:bodyPr/>
@@ -2341,73 +2307,8 @@
                     </a:lnB>
                   </a:tcPr>
                 </a:tc>
-                <a:tc>
-                  <a:txBody>
-                    <a:bodyPr/>
-                    <a:lstStyle/>
-                    <a:p>
-                      <a:pPr indent="0" marL="0">
-                        <a:buNone/>
-                      </a:pPr>
-                      <a:r>
-                        <a:rPr lang="en-US" sz="1400" dirty="0">
-                          <a:solidFill>
-                            <a:schemeClr val="tx1"/>
-                          </a:solidFill>
-                          <a:latin typeface="Arial" pitchFamily="34" charset="0"/>
-                          <a:ea typeface="Arial" pitchFamily="34" charset="-122"/>
-                          <a:cs typeface="Arial" pitchFamily="34" charset="-120"/>
-                        </a:rPr>
-                        <a:t>77.6%</a:t>
-                      </a:r>
-                      <a:endParaRPr lang="en-US" sz="1400" dirty="0">
-                        <a:latin typeface="Arial" charset="0"/>
-                        <a:ea typeface="Arial" charset="0"/>
-                        <a:cs typeface="Arial" charset="0"/>
-                      </a:endParaRPr>
-                    </a:p>
-                  </a:txBody>
-                  <a:tcPr marL="54864" marR="54864" marT="54864" marB="54864" anchor="ctr">
-                    <a:lnL w="9525" cap="flat" cmpd="sng" algn="ctr">
-                      <a:solidFill>
-                        <a:srgbClr val="BFBFBF"/>
-                      </a:solidFill>
-                      <a:prstDash val="solid"/>
-                      <a:round/>
-                      <a:headEnd type="none" w="med" len="med"/>
-                      <a:tailEnd type="none" w="med" len="med"/>
-                    </a:lnL>
-                    <a:lnR w="9525" cap="flat" cmpd="sng" algn="ctr">
-                      <a:solidFill>
-                        <a:srgbClr val="BFBFBF"/>
-                      </a:solidFill>
-                      <a:prstDash val="solid"/>
-                      <a:round/>
-                      <a:headEnd type="none" w="med" len="med"/>
-                      <a:tailEnd type="none" w="med" len="med"/>
-                    </a:lnR>
-                    <a:lnT w="9525" cap="flat" cmpd="sng" algn="ctr">
-                      <a:solidFill>
-                        <a:srgbClr val="BFBFBF"/>
-                      </a:solidFill>
-                      <a:prstDash val="solid"/>
-                      <a:round/>
-                      <a:headEnd type="none" w="med" len="med"/>
-                      <a:tailEnd type="none" w="med" len="med"/>
-                    </a:lnT>
-                    <a:lnB w="9525" cap="flat" cmpd="sng" algn="ctr">
-                      <a:solidFill>
-                        <a:srgbClr val="BFBFBF"/>
-                      </a:solidFill>
-                      <a:prstDash val="solid"/>
-                      <a:round/>
-                      <a:headEnd type="none" w="med" len="med"/>
-                      <a:tailEnd type="none" w="med" len="med"/>
-                    </a:lnB>
-                  </a:tcPr>
-                </a:tc>
               </a:tr>
-              <a:tr h="384048">
+              <a:tr h="365760">
                 <a:tc>
                   <a:txBody>
                     <a:bodyPr/>
@@ -2538,73 +2439,8 @@
                     </a:lnB>
                   </a:tcPr>
                 </a:tc>
-                <a:tc>
-                  <a:txBody>
-                    <a:bodyPr/>
-                    <a:lstStyle/>
-                    <a:p>
-                      <a:pPr indent="0" marL="0">
-                        <a:buNone/>
-                      </a:pPr>
-                      <a:r>
-                        <a:rPr lang="en-US" sz="1400" dirty="0">
-                          <a:solidFill>
-                            <a:schemeClr val="tx1"/>
-                          </a:solidFill>
-                          <a:latin typeface="Arial" pitchFamily="34" charset="0"/>
-                          <a:ea typeface="Arial" pitchFamily="34" charset="-122"/>
-                          <a:cs typeface="Arial" pitchFamily="34" charset="-120"/>
-                        </a:rPr>
-                        <a:t>94–100%</a:t>
-                      </a:r>
-                      <a:endParaRPr lang="en-US" sz="1400" dirty="0">
-                        <a:latin typeface="Arial" charset="0"/>
-                        <a:ea typeface="Arial" charset="0"/>
-                        <a:cs typeface="Arial" charset="0"/>
-                      </a:endParaRPr>
-                    </a:p>
-                  </a:txBody>
-                  <a:tcPr marL="54864" marR="54864" marT="54864" marB="54864" anchor="ctr">
-                    <a:lnL w="9525" cap="flat" cmpd="sng" algn="ctr">
-                      <a:solidFill>
-                        <a:srgbClr val="BFBFBF"/>
-                      </a:solidFill>
-                      <a:prstDash val="solid"/>
-                      <a:round/>
-                      <a:headEnd type="none" w="med" len="med"/>
-                      <a:tailEnd type="none" w="med" len="med"/>
-                    </a:lnL>
-                    <a:lnR w="9525" cap="flat" cmpd="sng" algn="ctr">
-                      <a:solidFill>
-                        <a:srgbClr val="BFBFBF"/>
-                      </a:solidFill>
-                      <a:prstDash val="solid"/>
-                      <a:round/>
-                      <a:headEnd type="none" w="med" len="med"/>
-                      <a:tailEnd type="none" w="med" len="med"/>
-                    </a:lnR>
-                    <a:lnT w="9525" cap="flat" cmpd="sng" algn="ctr">
-                      <a:solidFill>
-                        <a:srgbClr val="BFBFBF"/>
-                      </a:solidFill>
-                      <a:prstDash val="solid"/>
-                      <a:round/>
-                      <a:headEnd type="none" w="med" len="med"/>
-                      <a:tailEnd type="none" w="med" len="med"/>
-                    </a:lnT>
-                    <a:lnB w="9525" cap="flat" cmpd="sng" algn="ctr">
-                      <a:solidFill>
-                        <a:srgbClr val="BFBFBF"/>
-                      </a:solidFill>
-                      <a:prstDash val="solid"/>
-                      <a:round/>
-                      <a:headEnd type="none" w="med" len="med"/>
-                      <a:tailEnd type="none" w="med" len="med"/>
-                    </a:lnB>
-                  </a:tcPr>
-                </a:tc>
               </a:tr>
-              <a:tr h="384048">
+              <a:tr h="365760">
                 <a:tc>
                   <a:txBody>
                     <a:bodyPr/>
@@ -2735,73 +2571,8 @@
                     </a:lnB>
                   </a:tcPr>
                 </a:tc>
-                <a:tc>
-                  <a:txBody>
-                    <a:bodyPr/>
-                    <a:lstStyle/>
-                    <a:p>
-                      <a:pPr indent="0" marL="0">
-                        <a:buNone/>
-                      </a:pPr>
-                      <a:r>
-                        <a:rPr lang="en-US" sz="1400" dirty="0">
-                          <a:solidFill>
-                            <a:schemeClr val="tx1"/>
-                          </a:solidFill>
-                          <a:latin typeface="Arial" pitchFamily="34" charset="0"/>
-                          <a:ea typeface="Arial" pitchFamily="34" charset="-122"/>
-                          <a:cs typeface="Arial" pitchFamily="34" charset="-120"/>
-                        </a:rPr>
-                        <a:t>0 s</a:t>
-                      </a:r>
-                      <a:endParaRPr lang="en-US" sz="1400" dirty="0">
-                        <a:latin typeface="Arial" charset="0"/>
-                        <a:ea typeface="Arial" charset="0"/>
-                        <a:cs typeface="Arial" charset="0"/>
-                      </a:endParaRPr>
-                    </a:p>
-                  </a:txBody>
-                  <a:tcPr marL="54864" marR="54864" marT="54864" marB="54864" anchor="ctr">
-                    <a:lnL w="9525" cap="flat" cmpd="sng" algn="ctr">
-                      <a:solidFill>
-                        <a:srgbClr val="BFBFBF"/>
-                      </a:solidFill>
-                      <a:prstDash val="solid"/>
-                      <a:round/>
-                      <a:headEnd type="none" w="med" len="med"/>
-                      <a:tailEnd type="none" w="med" len="med"/>
-                    </a:lnL>
-                    <a:lnR w="9525" cap="flat" cmpd="sng" algn="ctr">
-                      <a:solidFill>
-                        <a:srgbClr val="BFBFBF"/>
-                      </a:solidFill>
-                      <a:prstDash val="solid"/>
-                      <a:round/>
-                      <a:headEnd type="none" w="med" len="med"/>
-                      <a:tailEnd type="none" w="med" len="med"/>
-                    </a:lnR>
-                    <a:lnT w="9525" cap="flat" cmpd="sng" algn="ctr">
-                      <a:solidFill>
-                        <a:srgbClr val="BFBFBF"/>
-                      </a:solidFill>
-                      <a:prstDash val="solid"/>
-                      <a:round/>
-                      <a:headEnd type="none" w="med" len="med"/>
-                      <a:tailEnd type="none" w="med" len="med"/>
-                    </a:lnT>
-                    <a:lnB w="9525" cap="flat" cmpd="sng" algn="ctr">
-                      <a:solidFill>
-                        <a:srgbClr val="BFBFBF"/>
-                      </a:solidFill>
-                      <a:prstDash val="solid"/>
-                      <a:round/>
-                      <a:headEnd type="none" w="med" len="med"/>
-                      <a:tailEnd type="none" w="med" len="med"/>
-                    </a:lnB>
-                  </a:tcPr>
-                </a:tc>
               </a:tr>
-              <a:tr h="384048">
+              <a:tr h="365760">
                 <a:tc>
                   <a:txBody>
                     <a:bodyPr/>
@@ -2932,73 +2703,8 @@
                     </a:lnB>
                   </a:tcPr>
                 </a:tc>
-                <a:tc>
-                  <a:txBody>
-                    <a:bodyPr/>
-                    <a:lstStyle/>
-                    <a:p>
-                      <a:pPr indent="0" marL="0">
-                        <a:buNone/>
-                      </a:pPr>
-                      <a:r>
-                        <a:rPr lang="en-US" sz="1400" dirty="0">
-                          <a:solidFill>
-                            <a:schemeClr val="tx1"/>
-                          </a:solidFill>
-                          <a:latin typeface="Arial" pitchFamily="34" charset="0"/>
-                          <a:ea typeface="Arial" pitchFamily="34" charset="-122"/>
-                          <a:cs typeface="Arial" pitchFamily="34" charset="-120"/>
-                        </a:rPr>
-                        <a:t>4.1</a:t>
-                      </a:r>
-                      <a:endParaRPr lang="en-US" sz="1400" dirty="0">
-                        <a:latin typeface="Arial" charset="0"/>
-                        <a:ea typeface="Arial" charset="0"/>
-                        <a:cs typeface="Arial" charset="0"/>
-                      </a:endParaRPr>
-                    </a:p>
-                  </a:txBody>
-                  <a:tcPr marL="54864" marR="54864" marT="54864" marB="54864" anchor="ctr">
-                    <a:lnL w="9525" cap="flat" cmpd="sng" algn="ctr">
-                      <a:solidFill>
-                        <a:srgbClr val="BFBFBF"/>
-                      </a:solidFill>
-                      <a:prstDash val="solid"/>
-                      <a:round/>
-                      <a:headEnd type="none" w="med" len="med"/>
-                      <a:tailEnd type="none" w="med" len="med"/>
-                    </a:lnL>
-                    <a:lnR w="9525" cap="flat" cmpd="sng" algn="ctr">
-                      <a:solidFill>
-                        <a:srgbClr val="BFBFBF"/>
-                      </a:solidFill>
-                      <a:prstDash val="solid"/>
-                      <a:round/>
-                      <a:headEnd type="none" w="med" len="med"/>
-                      <a:tailEnd type="none" w="med" len="med"/>
-                    </a:lnR>
-                    <a:lnT w="9525" cap="flat" cmpd="sng" algn="ctr">
-                      <a:solidFill>
-                        <a:srgbClr val="BFBFBF"/>
-                      </a:solidFill>
-                      <a:prstDash val="solid"/>
-                      <a:round/>
-                      <a:headEnd type="none" w="med" len="med"/>
-                      <a:tailEnd type="none" w="med" len="med"/>
-                    </a:lnT>
-                    <a:lnB w="9525" cap="flat" cmpd="sng" algn="ctr">
-                      <a:solidFill>
-                        <a:srgbClr val="BFBFBF"/>
-                      </a:solidFill>
-                      <a:prstDash val="solid"/>
-                      <a:round/>
-                      <a:headEnd type="none" w="med" len="med"/>
-                      <a:tailEnd type="none" w="med" len="med"/>
-                    </a:lnB>
-                  </a:tcPr>
-                </a:tc>
               </a:tr>
-              <a:tr h="384048">
+              <a:tr h="365760">
                 <a:tc>
                   <a:txBody>
                     <a:bodyPr/>
@@ -3129,71 +2835,6 @@
                     </a:lnB>
                   </a:tcPr>
                 </a:tc>
-                <a:tc>
-                  <a:txBody>
-                    <a:bodyPr/>
-                    <a:lstStyle/>
-                    <a:p>
-                      <a:pPr indent="0" marL="0">
-                        <a:buNone/>
-                      </a:pPr>
-                      <a:r>
-                        <a:rPr lang="en-US" sz="1400" dirty="0">
-                          <a:solidFill>
-                            <a:schemeClr val="tx1"/>
-                          </a:solidFill>
-                          <a:latin typeface="Arial" pitchFamily="34" charset="0"/>
-                          <a:ea typeface="Arial" pitchFamily="34" charset="-122"/>
-                          <a:cs typeface="Arial" pitchFamily="34" charset="-120"/>
-                        </a:rPr>
-                        <a:t>93.8%</a:t>
-                      </a:r>
-                      <a:endParaRPr lang="en-US" sz="1400" dirty="0">
-                        <a:latin typeface="Arial" charset="0"/>
-                        <a:ea typeface="Arial" charset="0"/>
-                        <a:cs typeface="Arial" charset="0"/>
-                      </a:endParaRPr>
-                    </a:p>
-                  </a:txBody>
-                  <a:tcPr marL="54864" marR="54864" marT="54864" marB="54864" anchor="ctr">
-                    <a:lnL w="9525" cap="flat" cmpd="sng" algn="ctr">
-                      <a:solidFill>
-                        <a:srgbClr val="BFBFBF"/>
-                      </a:solidFill>
-                      <a:prstDash val="solid"/>
-                      <a:round/>
-                      <a:headEnd type="none" w="med" len="med"/>
-                      <a:tailEnd type="none" w="med" len="med"/>
-                    </a:lnL>
-                    <a:lnR w="9525" cap="flat" cmpd="sng" algn="ctr">
-                      <a:solidFill>
-                        <a:srgbClr val="BFBFBF"/>
-                      </a:solidFill>
-                      <a:prstDash val="solid"/>
-                      <a:round/>
-                      <a:headEnd type="none" w="med" len="med"/>
-                      <a:tailEnd type="none" w="med" len="med"/>
-                    </a:lnR>
-                    <a:lnT w="9525" cap="flat" cmpd="sng" algn="ctr">
-                      <a:solidFill>
-                        <a:srgbClr val="BFBFBF"/>
-                      </a:solidFill>
-                      <a:prstDash val="solid"/>
-                      <a:round/>
-                      <a:headEnd type="none" w="med" len="med"/>
-                      <a:tailEnd type="none" w="med" len="med"/>
-                    </a:lnT>
-                    <a:lnB w="9525" cap="flat" cmpd="sng" algn="ctr">
-                      <a:solidFill>
-                        <a:srgbClr val="BFBFBF"/>
-                      </a:solidFill>
-                      <a:prstDash val="solid"/>
-                      <a:round/>
-                      <a:headEnd type="none" w="med" len="med"/>
-                      <a:tailEnd type="none" w="med" len="med"/>
-                    </a:lnB>
-                  </a:tcPr>
-                </a:tc>
               </a:tr>
             </a:tbl>
           </a:graphicData>
@@ -3201,14 +2842,14 @@
       </p:graphicFrame>
       <p:sp>
         <p:nvSpPr>
-          <p:cNvPr id="4" name="Text 1"/>
+          <p:cNvPr id="5" name="Text 1"/>
           <p:cNvSpPr txBox="1"/>
           <p:nvPr/>
         </p:nvSpPr>
         <p:spPr>
           <a:xfrm>
-            <a:off x="411480" y="3703320"/>
-            <a:ext cx="8321040" cy="914400"/>
+            <a:off x="4114800" y="3474720"/>
+            <a:ext cx="4617720" cy="1143000"/>
           </a:xfrm>
           <a:prstGeom prst="rect">
             <a:avLst/>
@@ -3222,38 +2863,38 @@
           <a:p>
             <a:pPr marL="342900" indent="-342900">
               <a:spcAft>
-                <a:spcPts val="800"/>
+                <a:spcPts val="600"/>
               </a:spcAft>
               <a:buSzPct val="100000"/>
               <a:buChar char="•"/>
             </a:pPr>
             <a:r>
-              <a:rPr lang="en-US" sz="1600" dirty="0">
+              <a:rPr lang="en-US" sz="1400" dirty="0">
                 <a:solidFill>
                   <a:schemeClr val="tx2"/>
                 </a:solidFill>
               </a:rPr>
-              <a:t>Scored per eating episode, the way a user would experience the device</a:t>
+              <a:t>Left: 8 s windows. Right: whole eating episodes, the way a user would experience the device</a:t>
             </a:r>
-            <a:endParaRPr lang="en-US" sz="1600" dirty="0"/>
+            <a:endParaRPr lang="en-US" sz="1400" dirty="0"/>
           </a:p>
           <a:p>
             <a:pPr marL="342900" indent="-342900">
               <a:spcAft>
-                <a:spcPts val="800"/>
+                <a:spcPts val="600"/>
               </a:spcAft>
               <a:buSzPct val="100000"/>
               <a:buChar char="•"/>
             </a:pPr>
             <a:r>
-              <a:rPr lang="en-US" sz="1600" dirty="0">
+              <a:rPr lang="en-US" sz="1400" dirty="0">
                 <a:solidFill>
                   <a:schemeClr val="tx2"/>
                 </a:solidFill>
               </a:rPr>
               <a:t>75% of false-alarm windows sit right next to a real meal</a:t>
             </a:r>
-            <a:endParaRPr lang="en-US" sz="1600" dirty="0"/>
+            <a:endParaRPr lang="en-US" sz="1400" dirty="0"/>
           </a:p>
         </p:txBody>
       </p:sp>
@@ -3367,14 +3008,338 @@
       </p:sp>
       <p:sp>
         <p:nvSpPr>
-          <p:cNvPr id="3" name="Text 1"/>
+          <p:cNvPr id="3" name="Shape 1"/>
+          <p:cNvSpPr/>
+          <p:nvPr/>
+        </p:nvSpPr>
+        <p:spPr>
+          <a:xfrm>
+            <a:off x="411480" y="1097280"/>
+            <a:ext cx="1783080" cy="822960"/>
+          </a:xfrm>
+          <a:prstGeom prst="roundRect">
+            <a:avLst>
+              <a:gd name="adj" fmla="val 8889"/>
+            </a:avLst>
+          </a:prstGeom>
+          <a:solidFill>
+            <a:srgbClr val="F2F2F2"/>
+          </a:solidFill>
+          <a:ln w="9525">
+            <a:solidFill>
+              <a:srgbClr val="BFBFBF"/>
+            </a:solidFill>
+            <a:prstDash val="solid"/>
+          </a:ln>
+        </p:spPr>
+      </p:sp>
+      <p:sp>
+        <p:nvSpPr>
+          <p:cNvPr id="4" name="Text 2"/>
           <p:cNvSpPr txBox="1"/>
           <p:nvPr/>
         </p:nvSpPr>
         <p:spPr>
           <a:xfrm>
-            <a:off x="411480" y="1143000"/>
-            <a:ext cx="8321040" cy="1097280"/>
+            <a:off x="411480" y="1097280"/>
+            <a:ext cx="1783080" cy="822960"/>
+          </a:xfrm>
+          <a:prstGeom prst="rect">
+            <a:avLst/>
+          </a:prstGeom>
+          <a:noFill/>
+          <a:ln/>
+        </p:spPr>
+        <p:txBody>
+          <a:bodyPr wrap="square" rtlCol="0" anchor="ctr"/>
+          <a:lstStyle/>
+          <a:p>
+            <a:pPr algn="ctr" indent="0" marL="0">
+              <a:buNone/>
+            </a:pPr>
+            <a:r>
+              <a:rPr lang="en-US" sz="1300" dirty="0">
+                <a:solidFill>
+                  <a:schemeClr val="tx1"/>
+                </a:solidFill>
+              </a:rPr>
+              <a:t>Raw AIM-2 recording</a:t>
+            </a:r>
+            <a:endParaRPr lang="en-US" sz="1300" dirty="0"/>
+          </a:p>
+        </p:txBody>
+      </p:sp>
+      <p:sp>
+        <p:nvSpPr>
+          <p:cNvPr id="5" name="Shape 3"/>
+          <p:cNvSpPr/>
+          <p:nvPr/>
+        </p:nvSpPr>
+        <p:spPr>
+          <a:xfrm>
+            <a:off x="2221992" y="1508760"/>
+            <a:ext cx="292608" cy="0"/>
+          </a:xfrm>
+          <a:prstGeom prst="line">
+            <a:avLst/>
+          </a:prstGeom>
+          <a:noFill/>
+          <a:ln w="19050">
+            <a:solidFill>
+              <a:srgbClr val="7F7F7F"/>
+            </a:solidFill>
+            <a:prstDash val="solid"/>
+            <a:tailEnd type="triangle"/>
+          </a:ln>
+        </p:spPr>
+      </p:sp>
+      <p:sp>
+        <p:nvSpPr>
+          <p:cNvPr id="6" name="Shape 4"/>
+          <p:cNvSpPr/>
+          <p:nvPr/>
+        </p:nvSpPr>
+        <p:spPr>
+          <a:xfrm>
+            <a:off x="2542032" y="1097280"/>
+            <a:ext cx="1783080" cy="822960"/>
+          </a:xfrm>
+          <a:prstGeom prst="roundRect">
+            <a:avLst>
+              <a:gd name="adj" fmla="val 8889"/>
+            </a:avLst>
+          </a:prstGeom>
+          <a:solidFill>
+            <a:srgbClr val="F2F2F2"/>
+          </a:solidFill>
+          <a:ln w="9525">
+            <a:solidFill>
+              <a:srgbClr val="BFBFBF"/>
+            </a:solidFill>
+            <a:prstDash val="solid"/>
+          </a:ln>
+        </p:spPr>
+      </p:sp>
+      <p:sp>
+        <p:nvSpPr>
+          <p:cNvPr id="7" name="Text 5"/>
+          <p:cNvSpPr txBox="1"/>
+          <p:nvPr/>
+        </p:nvSpPr>
+        <p:spPr>
+          <a:xfrm>
+            <a:off x="2542032" y="1097280"/>
+            <a:ext cx="1783080" cy="822960"/>
+          </a:xfrm>
+          <a:prstGeom prst="rect">
+            <a:avLst/>
+          </a:prstGeom>
+          <a:noFill/>
+          <a:ln/>
+        </p:spPr>
+        <p:txBody>
+          <a:bodyPr wrap="square" rtlCol="0" anchor="ctr"/>
+          <a:lstStyle/>
+          <a:p>
+            <a:pPr algn="ctr" indent="0" marL="0">
+              <a:buNone/>
+            </a:pPr>
+            <a:r>
+              <a:rPr lang="en-US" sz="1300" dirty="0">
+                <a:solidFill>
+                  <a:schemeClr val="tx1"/>
+                </a:solidFill>
+              </a:rPr>
+              <a:t>8 s windows</a:t>
+            </a:r>
+            <a:endParaRPr lang="en-US" sz="1300" dirty="0"/>
+          </a:p>
+        </p:txBody>
+      </p:sp>
+      <p:sp>
+        <p:nvSpPr>
+          <p:cNvPr id="8" name="Shape 6"/>
+          <p:cNvSpPr/>
+          <p:nvPr/>
+        </p:nvSpPr>
+        <p:spPr>
+          <a:xfrm>
+            <a:off x="4352544" y="1508760"/>
+            <a:ext cx="292608" cy="0"/>
+          </a:xfrm>
+          <a:prstGeom prst="line">
+            <a:avLst/>
+          </a:prstGeom>
+          <a:noFill/>
+          <a:ln w="19050">
+            <a:solidFill>
+              <a:srgbClr val="7F7F7F"/>
+            </a:solidFill>
+            <a:prstDash val="solid"/>
+            <a:tailEnd type="triangle"/>
+          </a:ln>
+        </p:spPr>
+      </p:sp>
+      <p:sp>
+        <p:nvSpPr>
+          <p:cNvPr id="9" name="Shape 7"/>
+          <p:cNvSpPr/>
+          <p:nvPr/>
+        </p:nvSpPr>
+        <p:spPr>
+          <a:xfrm>
+            <a:off x="4672584" y="1097280"/>
+            <a:ext cx="1783080" cy="822960"/>
+          </a:xfrm>
+          <a:prstGeom prst="roundRect">
+            <a:avLst>
+              <a:gd name="adj" fmla="val 8889"/>
+            </a:avLst>
+          </a:prstGeom>
+          <a:solidFill>
+            <a:srgbClr val="F2F2F2"/>
+          </a:solidFill>
+          <a:ln w="9525">
+            <a:solidFill>
+              <a:srgbClr val="BFBFBF"/>
+            </a:solidFill>
+            <a:prstDash val="solid"/>
+          </a:ln>
+        </p:spPr>
+      </p:sp>
+      <p:sp>
+        <p:nvSpPr>
+          <p:cNvPr id="10" name="Text 8"/>
+          <p:cNvSpPr txBox="1"/>
+          <p:nvPr/>
+        </p:nvSpPr>
+        <p:spPr>
+          <a:xfrm>
+            <a:off x="4672584" y="1097280"/>
+            <a:ext cx="1783080" cy="822960"/>
+          </a:xfrm>
+          <a:prstGeom prst="rect">
+            <a:avLst/>
+          </a:prstGeom>
+          <a:noFill/>
+          <a:ln/>
+        </p:spPr>
+        <p:txBody>
+          <a:bodyPr wrap="square" rtlCol="0" anchor="ctr"/>
+          <a:lstStyle/>
+          <a:p>
+            <a:pPr algn="ctr" indent="0" marL="0">
+              <a:buNone/>
+            </a:pPr>
+            <a:r>
+              <a:rPr lang="en-US" sz="1300" dirty="0">
+                <a:solidFill>
+                  <a:schemeClr val="tx1"/>
+                </a:solidFill>
+              </a:rPr>
+              <a:t>Model: probability of eating</a:t>
+            </a:r>
+            <a:endParaRPr lang="en-US" sz="1300" dirty="0"/>
+          </a:p>
+        </p:txBody>
+      </p:sp>
+      <p:sp>
+        <p:nvSpPr>
+          <p:cNvPr id="11" name="Shape 9"/>
+          <p:cNvSpPr/>
+          <p:nvPr/>
+        </p:nvSpPr>
+        <p:spPr>
+          <a:xfrm>
+            <a:off x="6483096" y="1508760"/>
+            <a:ext cx="292608" cy="0"/>
+          </a:xfrm>
+          <a:prstGeom prst="line">
+            <a:avLst/>
+          </a:prstGeom>
+          <a:noFill/>
+          <a:ln w="19050">
+            <a:solidFill>
+              <a:srgbClr val="7F7F7F"/>
+            </a:solidFill>
+            <a:prstDash val="solid"/>
+            <a:tailEnd type="triangle"/>
+          </a:ln>
+        </p:spPr>
+      </p:sp>
+      <p:sp>
+        <p:nvSpPr>
+          <p:cNvPr id="12" name="Shape 10"/>
+          <p:cNvSpPr/>
+          <p:nvPr/>
+        </p:nvSpPr>
+        <p:spPr>
+          <a:xfrm>
+            <a:off x="6803136" y="1097280"/>
+            <a:ext cx="1783080" cy="822960"/>
+          </a:xfrm>
+          <a:prstGeom prst="roundRect">
+            <a:avLst>
+              <a:gd name="adj" fmla="val 8889"/>
+            </a:avLst>
+          </a:prstGeom>
+          <a:solidFill>
+            <a:srgbClr val="F2F2F2"/>
+          </a:solidFill>
+          <a:ln w="9525">
+            <a:solidFill>
+              <a:srgbClr val="BFBFBF"/>
+            </a:solidFill>
+            <a:prstDash val="solid"/>
+          </a:ln>
+        </p:spPr>
+      </p:sp>
+      <p:sp>
+        <p:nvSpPr>
+          <p:cNvPr id="13" name="Text 11"/>
+          <p:cNvSpPr txBox="1"/>
+          <p:nvPr/>
+        </p:nvSpPr>
+        <p:spPr>
+          <a:xfrm>
+            <a:off x="6803136" y="1097280"/>
+            <a:ext cx="1783080" cy="822960"/>
+          </a:xfrm>
+          <a:prstGeom prst="rect">
+            <a:avLst/>
+          </a:prstGeom>
+          <a:noFill/>
+          <a:ln/>
+        </p:spPr>
+        <p:txBody>
+          <a:bodyPr wrap="square" rtlCol="0" anchor="ctr"/>
+          <a:lstStyle/>
+          <a:p>
+            <a:pPr algn="ctr" indent="0" marL="0">
+              <a:buNone/>
+            </a:pPr>
+            <a:r>
+              <a:rPr lang="en-US" sz="1300" dirty="0">
+                <a:solidFill>
+                  <a:schemeClr val="tx1"/>
+                </a:solidFill>
+              </a:rPr>
+              <a:t>Eating episodes with start and end times</a:t>
+            </a:r>
+            <a:endParaRPr lang="en-US" sz="1300" dirty="0"/>
+          </a:p>
+        </p:txBody>
+      </p:sp>
+      <p:sp>
+        <p:nvSpPr>
+          <p:cNvPr id="14" name="Text 12"/>
+          <p:cNvSpPr txBox="1"/>
+          <p:nvPr/>
+        </p:nvSpPr>
+        <p:spPr>
+          <a:xfrm>
+            <a:off x="411480" y="2194560"/>
+            <a:ext cx="8321040" cy="320040"/>
           </a:xfrm>
           <a:prstGeom prst="rect">
             <a:avLst/>
@@ -3386,145 +3351,864 @@
           <a:bodyPr wrap="square" lIns="0" tIns="0" rIns="0" bIns="0" rtlCol="0" anchor="t"/>
           <a:lstStyle/>
           <a:p>
-            <a:pPr marL="342900" indent="-342900">
+            <a:pPr indent="0" marL="0">
               <a:spcAft>
                 <a:spcPts val="800"/>
               </a:spcAft>
-              <a:buSzPct val="100000"/>
-              <a:buChar char="•"/>
-            </a:pPr>
-            <a:r>
-              <a:rPr lang="en-US" sz="1600" dirty="0">
-                <a:solidFill>
-                  <a:schemeClr val="tx2"/>
-                </a:solidFill>
-              </a:rPr>
-              <a:t>train_final_model.py: trains the one model that ships (all participants, 5 for validation)</a:t>
-            </a:r>
-            <a:endParaRPr lang="en-US" sz="1600" dirty="0"/>
-          </a:p>
-          <a:p>
-            <a:pPr marL="342900" indent="-342900">
-              <a:spcAft>
-                <a:spcPts val="800"/>
-              </a:spcAft>
-              <a:buSzPct val="100000"/>
-              <a:buChar char="•"/>
-            </a:pPr>
-            <a:r>
-              <a:rPr lang="en-US" sz="1600" dirty="0">
-                <a:solidFill>
-                  <a:schemeClr val="tx2"/>
-                </a:solidFill>
-              </a:rPr>
-              <a:t>detect_eating.py: raw sensor data from the database in, eating episodes with start and end times out</a:t>
-            </a:r>
-            <a:endParaRPr lang="en-US" sz="1600" dirty="0"/>
-          </a:p>
-        </p:txBody>
-      </p:sp>
-      <p:sp>
-        <p:nvSpPr>
-          <p:cNvPr id="4" name="Text 2"/>
-          <p:cNvSpPr txBox="1"/>
-          <p:nvPr/>
-        </p:nvSpPr>
-        <p:spPr>
-          <a:xfrm>
-            <a:off x="411480" y="2377440"/>
-            <a:ext cx="8321040" cy="1463040"/>
-          </a:xfrm>
-          <a:prstGeom prst="rect">
-            <a:avLst/>
-          </a:prstGeom>
-          <a:solidFill>
-            <a:srgbClr val="F2F2F2"/>
-          </a:solidFill>
-          <a:ln/>
-        </p:spPr>
-        <p:txBody>
-          <a:bodyPr wrap="square" lIns="1905" tIns="1905" rIns="1905" bIns="1905" rtlCol="0" anchor="t"/>
-          <a:lstStyle/>
-          <a:p>
-            <a:pPr indent="0" marL="0">
               <a:buNone/>
             </a:pPr>
             <a:r>
-              <a:rPr lang="en-US" sz="1400" b="1" dirty="0">
+              <a:rPr lang="en-US" sz="1500" dirty="0">
                 <a:solidFill>
                   <a:schemeClr val="tx1"/>
                 </a:solidFill>
-                <a:latin typeface="Courier New" pitchFamily="34" charset="0"/>
-                <a:ea typeface="Courier New" pitchFamily="34" charset="-122"/>
-                <a:cs typeface="Courier New" pitchFamily="34" charset="-120"/>
               </a:rPr>
-              <a:t>AIM130163 / ETS_snack, 26.9 min recording</a:t>
+              <a:t>Example: AIM130163, snack session (27 min recording)</a:t>
             </a:r>
-            <a:endParaRPr lang="en-US" sz="1400" dirty="0"/>
-          </a:p>
-          <a:p>
-            <a:pPr indent="0" marL="0">
-              <a:buNone/>
-            </a:pPr>
-            <a:r>
-              <a:rPr lang="en-US" sz="1400" dirty="0">
-                <a:solidFill>
-                  <a:schemeClr val="tx1"/>
-                </a:solidFill>
-                <a:latin typeface="Courier New" pitchFamily="34" charset="0"/>
-                <a:ea typeface="Courier New" pitchFamily="34" charset="-122"/>
-                <a:cs typeface="Courier New" pitchFamily="34" charset="-120"/>
-              </a:rPr>
-              <a:t>2026-03-11 20:31:58 - 20:44:22   12.4 min</a:t>
-            </a:r>
-            <a:endParaRPr lang="en-US" sz="1400" dirty="0"/>
-          </a:p>
-          <a:p>
-            <a:pPr indent="0" marL="0">
-              <a:buNone/>
-            </a:pPr>
-            <a:r>
-              <a:rPr lang="en-US" sz="1400" dirty="0">
-                <a:solidFill>
-                  <a:schemeClr val="tx1"/>
-                </a:solidFill>
-                <a:latin typeface="Courier New" pitchFamily="34" charset="0"/>
-                <a:ea typeface="Courier New" pitchFamily="34" charset="-122"/>
-                <a:cs typeface="Courier New" pitchFamily="34" charset="-120"/>
-              </a:rPr>
-              <a:t>2026-03-11 20:47:42 - 20:47:50    0.1 min</a:t>
-            </a:r>
-            <a:endParaRPr lang="en-US" sz="1400" dirty="0"/>
-          </a:p>
-          <a:p>
-            <a:pPr indent="0" marL="0">
-              <a:buNone/>
-            </a:pPr>
-            <a:r>
-              <a:rPr lang="en-US" sz="1400" dirty="0">
-                <a:solidFill>
-                  <a:schemeClr val="tx1"/>
-                </a:solidFill>
-                <a:latin typeface="Courier New" pitchFamily="34" charset="0"/>
-                <a:ea typeface="Courier New" pitchFamily="34" charset="-122"/>
-                <a:cs typeface="Courier New" pitchFamily="34" charset="-120"/>
-              </a:rPr>
-              <a:t>Against the annotation: F1 0.935, recall 0.986</a:t>
-            </a:r>
-            <a:endParaRPr lang="en-US" sz="1400" dirty="0"/>
+            <a:endParaRPr lang="en-US" sz="1500" dirty="0"/>
           </a:p>
         </p:txBody>
       </p:sp>
-      <p:sp>
-        <p:nvSpPr>
-          <p:cNvPr id="5" name="Text 3"/>
+      <p:graphicFrame>
+        <p:nvGraphicFramePr>
+          <p:cNvPr id="5" name="Table 0"/>
+          <p:cNvGraphicFramePr>
+            <a:graphicFrameLocks noGrp="1"/>
+          </p:cNvGraphicFramePr>
+          <p:nvPr>
+            <p:extLst>
+              <p:ext uri="{D42A27DB-BD31-4B8C-83A1-F6EECF244321}">
+                <p14:modId xmlns:p14="http://schemas.microsoft.com/office/powerpoint/2010/main" val="1579011935"/>
+              </p:ext>
+            </p:extLst>
+          </p:nvPr>
+        </p:nvGraphicFramePr>
+        <p:xfrm>
+          <a:off x="411480" y="2606040"/>
+          <a:ext cx="8321040" cy="914400"/>
+        </p:xfrm>
+        <a:graphic>
+          <a:graphicData uri="http://schemas.openxmlformats.org/drawingml/2006/table">
+            <a:tbl>
+              <a:tblPr/>
+              <a:tblGrid>
+                <a:gridCol w="2011680"/>
+                <a:gridCol w="1737360"/>
+                <a:gridCol w="1737360"/>
+                <a:gridCol w="2834640"/>
+              </a:tblGrid>
+              <a:tr h="365760">
+                <a:tc>
+                  <a:txBody>
+                    <a:bodyPr/>
+                    <a:lstStyle/>
+                    <a:p>
+                      <a:pPr indent="0" marL="0">
+                        <a:buNone/>
+                      </a:pPr>
+                      <a:r>
+                        <a:rPr lang="en-US" sz="1400" b="1" dirty="0">
+                          <a:solidFill>
+                            <a:schemeClr val="tx1"/>
+                          </a:solidFill>
+                          <a:latin typeface="Arial" pitchFamily="34" charset="0"/>
+                          <a:ea typeface="Arial" pitchFamily="34" charset="-122"/>
+                          <a:cs typeface="Arial" pitchFamily="34" charset="-120"/>
+                        </a:rPr>
+                        <a:t>Detected episode</a:t>
+                      </a:r>
+                      <a:endParaRPr lang="en-US" sz="1400" dirty="0">
+                        <a:latin typeface="Arial" charset="0"/>
+                        <a:ea typeface="Arial" charset="0"/>
+                        <a:cs typeface="Arial" charset="0"/>
+                      </a:endParaRPr>
+                    </a:p>
+                  </a:txBody>
+                  <a:tcPr marL="54864" marR="54864" marT="54864" marB="54864" anchor="ctr">
+                    <a:lnL w="9525" cap="flat" cmpd="sng" algn="ctr">
+                      <a:solidFill>
+                        <a:srgbClr val="BFBFBF"/>
+                      </a:solidFill>
+                      <a:prstDash val="solid"/>
+                      <a:round/>
+                      <a:headEnd type="none" w="med" len="med"/>
+                      <a:tailEnd type="none" w="med" len="med"/>
+                    </a:lnL>
+                    <a:lnR w="9525" cap="flat" cmpd="sng" algn="ctr">
+                      <a:solidFill>
+                        <a:srgbClr val="BFBFBF"/>
+                      </a:solidFill>
+                      <a:prstDash val="solid"/>
+                      <a:round/>
+                      <a:headEnd type="none" w="med" len="med"/>
+                      <a:tailEnd type="none" w="med" len="med"/>
+                    </a:lnR>
+                    <a:lnT w="9525" cap="flat" cmpd="sng" algn="ctr">
+                      <a:solidFill>
+                        <a:srgbClr val="BFBFBF"/>
+                      </a:solidFill>
+                      <a:prstDash val="solid"/>
+                      <a:round/>
+                      <a:headEnd type="none" w="med" len="med"/>
+                      <a:tailEnd type="none" w="med" len="med"/>
+                    </a:lnT>
+                    <a:lnB w="9525" cap="flat" cmpd="sng" algn="ctr">
+                      <a:solidFill>
+                        <a:srgbClr val="BFBFBF"/>
+                      </a:solidFill>
+                      <a:prstDash val="solid"/>
+                      <a:round/>
+                      <a:headEnd type="none" w="med" len="med"/>
+                      <a:tailEnd type="none" w="med" len="med"/>
+                    </a:lnB>
+                    <a:solidFill>
+                      <a:srgbClr val="F2F2F2"/>
+                    </a:solidFill>
+                  </a:tcPr>
+                </a:tc>
+                <a:tc>
+                  <a:txBody>
+                    <a:bodyPr/>
+                    <a:lstStyle/>
+                    <a:p>
+                      <a:pPr indent="0" marL="0">
+                        <a:buNone/>
+                      </a:pPr>
+                      <a:r>
+                        <a:rPr lang="en-US" sz="1400" b="1" dirty="0">
+                          <a:solidFill>
+                            <a:schemeClr val="tx1"/>
+                          </a:solidFill>
+                          <a:latin typeface="Arial" pitchFamily="34" charset="0"/>
+                          <a:ea typeface="Arial" pitchFamily="34" charset="-122"/>
+                          <a:cs typeface="Arial" pitchFamily="34" charset="-120"/>
+                        </a:rPr>
+                        <a:t>Start</a:t>
+                      </a:r>
+                      <a:endParaRPr lang="en-US" sz="1400" dirty="0">
+                        <a:latin typeface="Arial" charset="0"/>
+                        <a:ea typeface="Arial" charset="0"/>
+                        <a:cs typeface="Arial" charset="0"/>
+                      </a:endParaRPr>
+                    </a:p>
+                  </a:txBody>
+                  <a:tcPr marL="54864" marR="54864" marT="54864" marB="54864" anchor="ctr">
+                    <a:lnL w="9525" cap="flat" cmpd="sng" algn="ctr">
+                      <a:solidFill>
+                        <a:srgbClr val="BFBFBF"/>
+                      </a:solidFill>
+                      <a:prstDash val="solid"/>
+                      <a:round/>
+                      <a:headEnd type="none" w="med" len="med"/>
+                      <a:tailEnd type="none" w="med" len="med"/>
+                    </a:lnL>
+                    <a:lnR w="9525" cap="flat" cmpd="sng" algn="ctr">
+                      <a:solidFill>
+                        <a:srgbClr val="BFBFBF"/>
+                      </a:solidFill>
+                      <a:prstDash val="solid"/>
+                      <a:round/>
+                      <a:headEnd type="none" w="med" len="med"/>
+                      <a:tailEnd type="none" w="med" len="med"/>
+                    </a:lnR>
+                    <a:lnT w="9525" cap="flat" cmpd="sng" algn="ctr">
+                      <a:solidFill>
+                        <a:srgbClr val="BFBFBF"/>
+                      </a:solidFill>
+                      <a:prstDash val="solid"/>
+                      <a:round/>
+                      <a:headEnd type="none" w="med" len="med"/>
+                      <a:tailEnd type="none" w="med" len="med"/>
+                    </a:lnT>
+                    <a:lnB w="9525" cap="flat" cmpd="sng" algn="ctr">
+                      <a:solidFill>
+                        <a:srgbClr val="BFBFBF"/>
+                      </a:solidFill>
+                      <a:prstDash val="solid"/>
+                      <a:round/>
+                      <a:headEnd type="none" w="med" len="med"/>
+                      <a:tailEnd type="none" w="med" len="med"/>
+                    </a:lnB>
+                    <a:solidFill>
+                      <a:srgbClr val="F2F2F2"/>
+                    </a:solidFill>
+                  </a:tcPr>
+                </a:tc>
+                <a:tc>
+                  <a:txBody>
+                    <a:bodyPr/>
+                    <a:lstStyle/>
+                    <a:p>
+                      <a:pPr indent="0" marL="0">
+                        <a:buNone/>
+                      </a:pPr>
+                      <a:r>
+                        <a:rPr lang="en-US" sz="1400" b="1" dirty="0">
+                          <a:solidFill>
+                            <a:schemeClr val="tx1"/>
+                          </a:solidFill>
+                          <a:latin typeface="Arial" pitchFamily="34" charset="0"/>
+                          <a:ea typeface="Arial" pitchFamily="34" charset="-122"/>
+                          <a:cs typeface="Arial" pitchFamily="34" charset="-120"/>
+                        </a:rPr>
+                        <a:t>End</a:t>
+                      </a:r>
+                      <a:endParaRPr lang="en-US" sz="1400" dirty="0">
+                        <a:latin typeface="Arial" charset="0"/>
+                        <a:ea typeface="Arial" charset="0"/>
+                        <a:cs typeface="Arial" charset="0"/>
+                      </a:endParaRPr>
+                    </a:p>
+                  </a:txBody>
+                  <a:tcPr marL="54864" marR="54864" marT="54864" marB="54864" anchor="ctr">
+                    <a:lnL w="9525" cap="flat" cmpd="sng" algn="ctr">
+                      <a:solidFill>
+                        <a:srgbClr val="BFBFBF"/>
+                      </a:solidFill>
+                      <a:prstDash val="solid"/>
+                      <a:round/>
+                      <a:headEnd type="none" w="med" len="med"/>
+                      <a:tailEnd type="none" w="med" len="med"/>
+                    </a:lnL>
+                    <a:lnR w="9525" cap="flat" cmpd="sng" algn="ctr">
+                      <a:solidFill>
+                        <a:srgbClr val="BFBFBF"/>
+                      </a:solidFill>
+                      <a:prstDash val="solid"/>
+                      <a:round/>
+                      <a:headEnd type="none" w="med" len="med"/>
+                      <a:tailEnd type="none" w="med" len="med"/>
+                    </a:lnR>
+                    <a:lnT w="9525" cap="flat" cmpd="sng" algn="ctr">
+                      <a:solidFill>
+                        <a:srgbClr val="BFBFBF"/>
+                      </a:solidFill>
+                      <a:prstDash val="solid"/>
+                      <a:round/>
+                      <a:headEnd type="none" w="med" len="med"/>
+                      <a:tailEnd type="none" w="med" len="med"/>
+                    </a:lnT>
+                    <a:lnB w="9525" cap="flat" cmpd="sng" algn="ctr">
+                      <a:solidFill>
+                        <a:srgbClr val="BFBFBF"/>
+                      </a:solidFill>
+                      <a:prstDash val="solid"/>
+                      <a:round/>
+                      <a:headEnd type="none" w="med" len="med"/>
+                      <a:tailEnd type="none" w="med" len="med"/>
+                    </a:lnB>
+                    <a:solidFill>
+                      <a:srgbClr val="F2F2F2"/>
+                    </a:solidFill>
+                  </a:tcPr>
+                </a:tc>
+                <a:tc>
+                  <a:txBody>
+                    <a:bodyPr/>
+                    <a:lstStyle/>
+                    <a:p>
+                      <a:pPr indent="0" marL="0">
+                        <a:buNone/>
+                      </a:pPr>
+                      <a:r>
+                        <a:rPr lang="en-US" sz="1400" b="1" dirty="0">
+                          <a:solidFill>
+                            <a:schemeClr val="tx1"/>
+                          </a:solidFill>
+                          <a:latin typeface="Arial" pitchFamily="34" charset="0"/>
+                          <a:ea typeface="Arial" pitchFamily="34" charset="-122"/>
+                          <a:cs typeface="Arial" pitchFamily="34" charset="-120"/>
+                        </a:rPr>
+                        <a:t>Duration</a:t>
+                      </a:r>
+                      <a:endParaRPr lang="en-US" sz="1400" dirty="0">
+                        <a:latin typeface="Arial" charset="0"/>
+                        <a:ea typeface="Arial" charset="0"/>
+                        <a:cs typeface="Arial" charset="0"/>
+                      </a:endParaRPr>
+                    </a:p>
+                  </a:txBody>
+                  <a:tcPr marL="54864" marR="54864" marT="54864" marB="54864" anchor="ctr">
+                    <a:lnL w="9525" cap="flat" cmpd="sng" algn="ctr">
+                      <a:solidFill>
+                        <a:srgbClr val="BFBFBF"/>
+                      </a:solidFill>
+                      <a:prstDash val="solid"/>
+                      <a:round/>
+                      <a:headEnd type="none" w="med" len="med"/>
+                      <a:tailEnd type="none" w="med" len="med"/>
+                    </a:lnL>
+                    <a:lnR w="9525" cap="flat" cmpd="sng" algn="ctr">
+                      <a:solidFill>
+                        <a:srgbClr val="BFBFBF"/>
+                      </a:solidFill>
+                      <a:prstDash val="solid"/>
+                      <a:round/>
+                      <a:headEnd type="none" w="med" len="med"/>
+                      <a:tailEnd type="none" w="med" len="med"/>
+                    </a:lnR>
+                    <a:lnT w="9525" cap="flat" cmpd="sng" algn="ctr">
+                      <a:solidFill>
+                        <a:srgbClr val="BFBFBF"/>
+                      </a:solidFill>
+                      <a:prstDash val="solid"/>
+                      <a:round/>
+                      <a:headEnd type="none" w="med" len="med"/>
+                      <a:tailEnd type="none" w="med" len="med"/>
+                    </a:lnT>
+                    <a:lnB w="9525" cap="flat" cmpd="sng" algn="ctr">
+                      <a:solidFill>
+                        <a:srgbClr val="BFBFBF"/>
+                      </a:solidFill>
+                      <a:prstDash val="solid"/>
+                      <a:round/>
+                      <a:headEnd type="none" w="med" len="med"/>
+                      <a:tailEnd type="none" w="med" len="med"/>
+                    </a:lnB>
+                    <a:solidFill>
+                      <a:srgbClr val="F2F2F2"/>
+                    </a:solidFill>
+                  </a:tcPr>
+                </a:tc>
+              </a:tr>
+              <a:tr h="365760">
+                <a:tc>
+                  <a:txBody>
+                    <a:bodyPr/>
+                    <a:lstStyle/>
+                    <a:p>
+                      <a:pPr indent="0" marL="0">
+                        <a:buNone/>
+                      </a:pPr>
+                      <a:r>
+                        <a:rPr lang="en-US" sz="1400" dirty="0">
+                          <a:solidFill>
+                            <a:schemeClr val="tx1"/>
+                          </a:solidFill>
+                          <a:latin typeface="Arial" pitchFamily="34" charset="0"/>
+                          <a:ea typeface="Arial" pitchFamily="34" charset="-122"/>
+                          <a:cs typeface="Arial" pitchFamily="34" charset="-120"/>
+                        </a:rPr>
+                        <a:t>1</a:t>
+                      </a:r>
+                      <a:endParaRPr lang="en-US" sz="1400" dirty="0">
+                        <a:latin typeface="Arial" charset="0"/>
+                        <a:ea typeface="Arial" charset="0"/>
+                        <a:cs typeface="Arial" charset="0"/>
+                      </a:endParaRPr>
+                    </a:p>
+                  </a:txBody>
+                  <a:tcPr marL="54864" marR="54864" marT="54864" marB="54864" anchor="ctr">
+                    <a:lnL w="9525" cap="flat" cmpd="sng" algn="ctr">
+                      <a:solidFill>
+                        <a:srgbClr val="BFBFBF"/>
+                      </a:solidFill>
+                      <a:prstDash val="solid"/>
+                      <a:round/>
+                      <a:headEnd type="none" w="med" len="med"/>
+                      <a:tailEnd type="none" w="med" len="med"/>
+                    </a:lnL>
+                    <a:lnR w="9525" cap="flat" cmpd="sng" algn="ctr">
+                      <a:solidFill>
+                        <a:srgbClr val="BFBFBF"/>
+                      </a:solidFill>
+                      <a:prstDash val="solid"/>
+                      <a:round/>
+                      <a:headEnd type="none" w="med" len="med"/>
+                      <a:tailEnd type="none" w="med" len="med"/>
+                    </a:lnR>
+                    <a:lnT w="9525" cap="flat" cmpd="sng" algn="ctr">
+                      <a:solidFill>
+                        <a:srgbClr val="BFBFBF"/>
+                      </a:solidFill>
+                      <a:prstDash val="solid"/>
+                      <a:round/>
+                      <a:headEnd type="none" w="med" len="med"/>
+                      <a:tailEnd type="none" w="med" len="med"/>
+                    </a:lnT>
+                    <a:lnB w="9525" cap="flat" cmpd="sng" algn="ctr">
+                      <a:solidFill>
+                        <a:srgbClr val="BFBFBF"/>
+                      </a:solidFill>
+                      <a:prstDash val="solid"/>
+                      <a:round/>
+                      <a:headEnd type="none" w="med" len="med"/>
+                      <a:tailEnd type="none" w="med" len="med"/>
+                    </a:lnB>
+                  </a:tcPr>
+                </a:tc>
+                <a:tc>
+                  <a:txBody>
+                    <a:bodyPr/>
+                    <a:lstStyle/>
+                    <a:p>
+                      <a:pPr indent="0" marL="0">
+                        <a:buNone/>
+                      </a:pPr>
+                      <a:r>
+                        <a:rPr lang="en-US" sz="1400" dirty="0">
+                          <a:solidFill>
+                            <a:schemeClr val="tx1"/>
+                          </a:solidFill>
+                          <a:latin typeface="Arial" pitchFamily="34" charset="0"/>
+                          <a:ea typeface="Arial" pitchFamily="34" charset="-122"/>
+                          <a:cs typeface="Arial" pitchFamily="34" charset="-120"/>
+                        </a:rPr>
+                        <a:t>20:31:58</a:t>
+                      </a:r>
+                      <a:endParaRPr lang="en-US" sz="1400" dirty="0">
+                        <a:latin typeface="Arial" charset="0"/>
+                        <a:ea typeface="Arial" charset="0"/>
+                        <a:cs typeface="Arial" charset="0"/>
+                      </a:endParaRPr>
+                    </a:p>
+                  </a:txBody>
+                  <a:tcPr marL="54864" marR="54864" marT="54864" marB="54864" anchor="ctr">
+                    <a:lnL w="9525" cap="flat" cmpd="sng" algn="ctr">
+                      <a:solidFill>
+                        <a:srgbClr val="BFBFBF"/>
+                      </a:solidFill>
+                      <a:prstDash val="solid"/>
+                      <a:round/>
+                      <a:headEnd type="none" w="med" len="med"/>
+                      <a:tailEnd type="none" w="med" len="med"/>
+                    </a:lnL>
+                    <a:lnR w="9525" cap="flat" cmpd="sng" algn="ctr">
+                      <a:solidFill>
+                        <a:srgbClr val="BFBFBF"/>
+                      </a:solidFill>
+                      <a:prstDash val="solid"/>
+                      <a:round/>
+                      <a:headEnd type="none" w="med" len="med"/>
+                      <a:tailEnd type="none" w="med" len="med"/>
+                    </a:lnR>
+                    <a:lnT w="9525" cap="flat" cmpd="sng" algn="ctr">
+                      <a:solidFill>
+                        <a:srgbClr val="BFBFBF"/>
+                      </a:solidFill>
+                      <a:prstDash val="solid"/>
+                      <a:round/>
+                      <a:headEnd type="none" w="med" len="med"/>
+                      <a:tailEnd type="none" w="med" len="med"/>
+                    </a:lnT>
+                    <a:lnB w="9525" cap="flat" cmpd="sng" algn="ctr">
+                      <a:solidFill>
+                        <a:srgbClr val="BFBFBF"/>
+                      </a:solidFill>
+                      <a:prstDash val="solid"/>
+                      <a:round/>
+                      <a:headEnd type="none" w="med" len="med"/>
+                      <a:tailEnd type="none" w="med" len="med"/>
+                    </a:lnB>
+                  </a:tcPr>
+                </a:tc>
+                <a:tc>
+                  <a:txBody>
+                    <a:bodyPr/>
+                    <a:lstStyle/>
+                    <a:p>
+                      <a:pPr indent="0" marL="0">
+                        <a:buNone/>
+                      </a:pPr>
+                      <a:r>
+                        <a:rPr lang="en-US" sz="1400" dirty="0">
+                          <a:solidFill>
+                            <a:schemeClr val="tx1"/>
+                          </a:solidFill>
+                          <a:latin typeface="Arial" pitchFamily="34" charset="0"/>
+                          <a:ea typeface="Arial" pitchFamily="34" charset="-122"/>
+                          <a:cs typeface="Arial" pitchFamily="34" charset="-120"/>
+                        </a:rPr>
+                        <a:t>20:44:22</a:t>
+                      </a:r>
+                      <a:endParaRPr lang="en-US" sz="1400" dirty="0">
+                        <a:latin typeface="Arial" charset="0"/>
+                        <a:ea typeface="Arial" charset="0"/>
+                        <a:cs typeface="Arial" charset="0"/>
+                      </a:endParaRPr>
+                    </a:p>
+                  </a:txBody>
+                  <a:tcPr marL="54864" marR="54864" marT="54864" marB="54864" anchor="ctr">
+                    <a:lnL w="9525" cap="flat" cmpd="sng" algn="ctr">
+                      <a:solidFill>
+                        <a:srgbClr val="BFBFBF"/>
+                      </a:solidFill>
+                      <a:prstDash val="solid"/>
+                      <a:round/>
+                      <a:headEnd type="none" w="med" len="med"/>
+                      <a:tailEnd type="none" w="med" len="med"/>
+                    </a:lnL>
+                    <a:lnR w="9525" cap="flat" cmpd="sng" algn="ctr">
+                      <a:solidFill>
+                        <a:srgbClr val="BFBFBF"/>
+                      </a:solidFill>
+                      <a:prstDash val="solid"/>
+                      <a:round/>
+                      <a:headEnd type="none" w="med" len="med"/>
+                      <a:tailEnd type="none" w="med" len="med"/>
+                    </a:lnR>
+                    <a:lnT w="9525" cap="flat" cmpd="sng" algn="ctr">
+                      <a:solidFill>
+                        <a:srgbClr val="BFBFBF"/>
+                      </a:solidFill>
+                      <a:prstDash val="solid"/>
+                      <a:round/>
+                      <a:headEnd type="none" w="med" len="med"/>
+                      <a:tailEnd type="none" w="med" len="med"/>
+                    </a:lnT>
+                    <a:lnB w="9525" cap="flat" cmpd="sng" algn="ctr">
+                      <a:solidFill>
+                        <a:srgbClr val="BFBFBF"/>
+                      </a:solidFill>
+                      <a:prstDash val="solid"/>
+                      <a:round/>
+                      <a:headEnd type="none" w="med" len="med"/>
+                      <a:tailEnd type="none" w="med" len="med"/>
+                    </a:lnB>
+                  </a:tcPr>
+                </a:tc>
+                <a:tc>
+                  <a:txBody>
+                    <a:bodyPr/>
+                    <a:lstStyle/>
+                    <a:p>
+                      <a:pPr indent="0" marL="0">
+                        <a:buNone/>
+                      </a:pPr>
+                      <a:r>
+                        <a:rPr lang="en-US" sz="1400" dirty="0">
+                          <a:solidFill>
+                            <a:schemeClr val="tx1"/>
+                          </a:solidFill>
+                          <a:latin typeface="Arial" pitchFamily="34" charset="0"/>
+                          <a:ea typeface="Arial" pitchFamily="34" charset="-122"/>
+                          <a:cs typeface="Arial" pitchFamily="34" charset="-120"/>
+                        </a:rPr>
+                        <a:t>12.4 min</a:t>
+                      </a:r>
+                      <a:endParaRPr lang="en-US" sz="1400" dirty="0">
+                        <a:latin typeface="Arial" charset="0"/>
+                        <a:ea typeface="Arial" charset="0"/>
+                        <a:cs typeface="Arial" charset="0"/>
+                      </a:endParaRPr>
+                    </a:p>
+                  </a:txBody>
+                  <a:tcPr marL="54864" marR="54864" marT="54864" marB="54864" anchor="ctr">
+                    <a:lnL w="9525" cap="flat" cmpd="sng" algn="ctr">
+                      <a:solidFill>
+                        <a:srgbClr val="BFBFBF"/>
+                      </a:solidFill>
+                      <a:prstDash val="solid"/>
+                      <a:round/>
+                      <a:headEnd type="none" w="med" len="med"/>
+                      <a:tailEnd type="none" w="med" len="med"/>
+                    </a:lnL>
+                    <a:lnR w="9525" cap="flat" cmpd="sng" algn="ctr">
+                      <a:solidFill>
+                        <a:srgbClr val="BFBFBF"/>
+                      </a:solidFill>
+                      <a:prstDash val="solid"/>
+                      <a:round/>
+                      <a:headEnd type="none" w="med" len="med"/>
+                      <a:tailEnd type="none" w="med" len="med"/>
+                    </a:lnR>
+                    <a:lnT w="9525" cap="flat" cmpd="sng" algn="ctr">
+                      <a:solidFill>
+                        <a:srgbClr val="BFBFBF"/>
+                      </a:solidFill>
+                      <a:prstDash val="solid"/>
+                      <a:round/>
+                      <a:headEnd type="none" w="med" len="med"/>
+                      <a:tailEnd type="none" w="med" len="med"/>
+                    </a:lnT>
+                    <a:lnB w="9525" cap="flat" cmpd="sng" algn="ctr">
+                      <a:solidFill>
+                        <a:srgbClr val="BFBFBF"/>
+                      </a:solidFill>
+                      <a:prstDash val="solid"/>
+                      <a:round/>
+                      <a:headEnd type="none" w="med" len="med"/>
+                      <a:tailEnd type="none" w="med" len="med"/>
+                    </a:lnB>
+                  </a:tcPr>
+                </a:tc>
+              </a:tr>
+              <a:tr h="365760">
+                <a:tc>
+                  <a:txBody>
+                    <a:bodyPr/>
+                    <a:lstStyle/>
+                    <a:p>
+                      <a:pPr indent="0" marL="0">
+                        <a:buNone/>
+                      </a:pPr>
+                      <a:r>
+                        <a:rPr lang="en-US" sz="1400" dirty="0">
+                          <a:solidFill>
+                            <a:schemeClr val="tx1"/>
+                          </a:solidFill>
+                          <a:latin typeface="Arial" pitchFamily="34" charset="0"/>
+                          <a:ea typeface="Arial" pitchFamily="34" charset="-122"/>
+                          <a:cs typeface="Arial" pitchFamily="34" charset="-120"/>
+                        </a:rPr>
+                        <a:t>2</a:t>
+                      </a:r>
+                      <a:endParaRPr lang="en-US" sz="1400" dirty="0">
+                        <a:latin typeface="Arial" charset="0"/>
+                        <a:ea typeface="Arial" charset="0"/>
+                        <a:cs typeface="Arial" charset="0"/>
+                      </a:endParaRPr>
+                    </a:p>
+                  </a:txBody>
+                  <a:tcPr marL="54864" marR="54864" marT="54864" marB="54864" anchor="ctr">
+                    <a:lnL w="9525" cap="flat" cmpd="sng" algn="ctr">
+                      <a:solidFill>
+                        <a:srgbClr val="BFBFBF"/>
+                      </a:solidFill>
+                      <a:prstDash val="solid"/>
+                      <a:round/>
+                      <a:headEnd type="none" w="med" len="med"/>
+                      <a:tailEnd type="none" w="med" len="med"/>
+                    </a:lnL>
+                    <a:lnR w="9525" cap="flat" cmpd="sng" algn="ctr">
+                      <a:solidFill>
+                        <a:srgbClr val="BFBFBF"/>
+                      </a:solidFill>
+                      <a:prstDash val="solid"/>
+                      <a:round/>
+                      <a:headEnd type="none" w="med" len="med"/>
+                      <a:tailEnd type="none" w="med" len="med"/>
+                    </a:lnR>
+                    <a:lnT w="9525" cap="flat" cmpd="sng" algn="ctr">
+                      <a:solidFill>
+                        <a:srgbClr val="BFBFBF"/>
+                      </a:solidFill>
+                      <a:prstDash val="solid"/>
+                      <a:round/>
+                      <a:headEnd type="none" w="med" len="med"/>
+                      <a:tailEnd type="none" w="med" len="med"/>
+                    </a:lnT>
+                    <a:lnB w="9525" cap="flat" cmpd="sng" algn="ctr">
+                      <a:solidFill>
+                        <a:srgbClr val="BFBFBF"/>
+                      </a:solidFill>
+                      <a:prstDash val="solid"/>
+                      <a:round/>
+                      <a:headEnd type="none" w="med" len="med"/>
+                      <a:tailEnd type="none" w="med" len="med"/>
+                    </a:lnB>
+                  </a:tcPr>
+                </a:tc>
+                <a:tc>
+                  <a:txBody>
+                    <a:bodyPr/>
+                    <a:lstStyle/>
+                    <a:p>
+                      <a:pPr indent="0" marL="0">
+                        <a:buNone/>
+                      </a:pPr>
+                      <a:r>
+                        <a:rPr lang="en-US" sz="1400" dirty="0">
+                          <a:solidFill>
+                            <a:schemeClr val="tx1"/>
+                          </a:solidFill>
+                          <a:latin typeface="Arial" pitchFamily="34" charset="0"/>
+                          <a:ea typeface="Arial" pitchFamily="34" charset="-122"/>
+                          <a:cs typeface="Arial" pitchFamily="34" charset="-120"/>
+                        </a:rPr>
+                        <a:t>20:47:42</a:t>
+                      </a:r>
+                      <a:endParaRPr lang="en-US" sz="1400" dirty="0">
+                        <a:latin typeface="Arial" charset="0"/>
+                        <a:ea typeface="Arial" charset="0"/>
+                        <a:cs typeface="Arial" charset="0"/>
+                      </a:endParaRPr>
+                    </a:p>
+                  </a:txBody>
+                  <a:tcPr marL="54864" marR="54864" marT="54864" marB="54864" anchor="ctr">
+                    <a:lnL w="9525" cap="flat" cmpd="sng" algn="ctr">
+                      <a:solidFill>
+                        <a:srgbClr val="BFBFBF"/>
+                      </a:solidFill>
+                      <a:prstDash val="solid"/>
+                      <a:round/>
+                      <a:headEnd type="none" w="med" len="med"/>
+                      <a:tailEnd type="none" w="med" len="med"/>
+                    </a:lnL>
+                    <a:lnR w="9525" cap="flat" cmpd="sng" algn="ctr">
+                      <a:solidFill>
+                        <a:srgbClr val="BFBFBF"/>
+                      </a:solidFill>
+                      <a:prstDash val="solid"/>
+                      <a:round/>
+                      <a:headEnd type="none" w="med" len="med"/>
+                      <a:tailEnd type="none" w="med" len="med"/>
+                    </a:lnR>
+                    <a:lnT w="9525" cap="flat" cmpd="sng" algn="ctr">
+                      <a:solidFill>
+                        <a:srgbClr val="BFBFBF"/>
+                      </a:solidFill>
+                      <a:prstDash val="solid"/>
+                      <a:round/>
+                      <a:headEnd type="none" w="med" len="med"/>
+                      <a:tailEnd type="none" w="med" len="med"/>
+                    </a:lnT>
+                    <a:lnB w="9525" cap="flat" cmpd="sng" algn="ctr">
+                      <a:solidFill>
+                        <a:srgbClr val="BFBFBF"/>
+                      </a:solidFill>
+                      <a:prstDash val="solid"/>
+                      <a:round/>
+                      <a:headEnd type="none" w="med" len="med"/>
+                      <a:tailEnd type="none" w="med" len="med"/>
+                    </a:lnB>
+                  </a:tcPr>
+                </a:tc>
+                <a:tc>
+                  <a:txBody>
+                    <a:bodyPr/>
+                    <a:lstStyle/>
+                    <a:p>
+                      <a:pPr indent="0" marL="0">
+                        <a:buNone/>
+                      </a:pPr>
+                      <a:r>
+                        <a:rPr lang="en-US" sz="1400" dirty="0">
+                          <a:solidFill>
+                            <a:schemeClr val="tx1"/>
+                          </a:solidFill>
+                          <a:latin typeface="Arial" pitchFamily="34" charset="0"/>
+                          <a:ea typeface="Arial" pitchFamily="34" charset="-122"/>
+                          <a:cs typeface="Arial" pitchFamily="34" charset="-120"/>
+                        </a:rPr>
+                        <a:t>20:47:50</a:t>
+                      </a:r>
+                      <a:endParaRPr lang="en-US" sz="1400" dirty="0">
+                        <a:latin typeface="Arial" charset="0"/>
+                        <a:ea typeface="Arial" charset="0"/>
+                        <a:cs typeface="Arial" charset="0"/>
+                      </a:endParaRPr>
+                    </a:p>
+                  </a:txBody>
+                  <a:tcPr marL="54864" marR="54864" marT="54864" marB="54864" anchor="ctr">
+                    <a:lnL w="9525" cap="flat" cmpd="sng" algn="ctr">
+                      <a:solidFill>
+                        <a:srgbClr val="BFBFBF"/>
+                      </a:solidFill>
+                      <a:prstDash val="solid"/>
+                      <a:round/>
+                      <a:headEnd type="none" w="med" len="med"/>
+                      <a:tailEnd type="none" w="med" len="med"/>
+                    </a:lnL>
+                    <a:lnR w="9525" cap="flat" cmpd="sng" algn="ctr">
+                      <a:solidFill>
+                        <a:srgbClr val="BFBFBF"/>
+                      </a:solidFill>
+                      <a:prstDash val="solid"/>
+                      <a:round/>
+                      <a:headEnd type="none" w="med" len="med"/>
+                      <a:tailEnd type="none" w="med" len="med"/>
+                    </a:lnR>
+                    <a:lnT w="9525" cap="flat" cmpd="sng" algn="ctr">
+                      <a:solidFill>
+                        <a:srgbClr val="BFBFBF"/>
+                      </a:solidFill>
+                      <a:prstDash val="solid"/>
+                      <a:round/>
+                      <a:headEnd type="none" w="med" len="med"/>
+                      <a:tailEnd type="none" w="med" len="med"/>
+                    </a:lnT>
+                    <a:lnB w="9525" cap="flat" cmpd="sng" algn="ctr">
+                      <a:solidFill>
+                        <a:srgbClr val="BFBFBF"/>
+                      </a:solidFill>
+                      <a:prstDash val="solid"/>
+                      <a:round/>
+                      <a:headEnd type="none" w="med" len="med"/>
+                      <a:tailEnd type="none" w="med" len="med"/>
+                    </a:lnB>
+                  </a:tcPr>
+                </a:tc>
+                <a:tc>
+                  <a:txBody>
+                    <a:bodyPr/>
+                    <a:lstStyle/>
+                    <a:p>
+                      <a:pPr indent="0" marL="0">
+                        <a:buNone/>
+                      </a:pPr>
+                      <a:r>
+                        <a:rPr lang="en-US" sz="1400" dirty="0">
+                          <a:solidFill>
+                            <a:schemeClr val="tx1"/>
+                          </a:solidFill>
+                          <a:latin typeface="Arial" pitchFamily="34" charset="0"/>
+                          <a:ea typeface="Arial" pitchFamily="34" charset="-122"/>
+                          <a:cs typeface="Arial" pitchFamily="34" charset="-120"/>
+                        </a:rPr>
+                        <a:t>8 s (one stray window)</a:t>
+                      </a:r>
+                      <a:endParaRPr lang="en-US" sz="1400" dirty="0">
+                        <a:latin typeface="Arial" charset="0"/>
+                        <a:ea typeface="Arial" charset="0"/>
+                        <a:cs typeface="Arial" charset="0"/>
+                      </a:endParaRPr>
+                    </a:p>
+                  </a:txBody>
+                  <a:tcPr marL="54864" marR="54864" marT="54864" marB="54864" anchor="ctr">
+                    <a:lnL w="9525" cap="flat" cmpd="sng" algn="ctr">
+                      <a:solidFill>
+                        <a:srgbClr val="BFBFBF"/>
+                      </a:solidFill>
+                      <a:prstDash val="solid"/>
+                      <a:round/>
+                      <a:headEnd type="none" w="med" len="med"/>
+                      <a:tailEnd type="none" w="med" len="med"/>
+                    </a:lnL>
+                    <a:lnR w="9525" cap="flat" cmpd="sng" algn="ctr">
+                      <a:solidFill>
+                        <a:srgbClr val="BFBFBF"/>
+                      </a:solidFill>
+                      <a:prstDash val="solid"/>
+                      <a:round/>
+                      <a:headEnd type="none" w="med" len="med"/>
+                      <a:tailEnd type="none" w="med" len="med"/>
+                    </a:lnR>
+                    <a:lnT w="9525" cap="flat" cmpd="sng" algn="ctr">
+                      <a:solidFill>
+                        <a:srgbClr val="BFBFBF"/>
+                      </a:solidFill>
+                      <a:prstDash val="solid"/>
+                      <a:round/>
+                      <a:headEnd type="none" w="med" len="med"/>
+                      <a:tailEnd type="none" w="med" len="med"/>
+                    </a:lnT>
+                    <a:lnB w="9525" cap="flat" cmpd="sng" algn="ctr">
+                      <a:solidFill>
+                        <a:srgbClr val="BFBFBF"/>
+                      </a:solidFill>
+                      <a:prstDash val="solid"/>
+                      <a:round/>
+                      <a:headEnd type="none" w="med" len="med"/>
+                      <a:tailEnd type="none" w="med" len="med"/>
+                    </a:lnB>
+                  </a:tcPr>
+                </a:tc>
+              </a:tr>
+            </a:tbl>
+          </a:graphicData>
+        </a:graphic>
+      </p:graphicFrame>
+      <p:sp>
+        <p:nvSpPr>
+          <p:cNvPr id="16" name="Text 13"/>
           <p:cNvSpPr txBox="1"/>
           <p:nvPr/>
         </p:nvSpPr>
         <p:spPr>
           <a:xfrm>
-            <a:off x="411480" y="4023360"/>
-            <a:ext cx="8321040" cy="457200"/>
+            <a:off x="411480" y="3840480"/>
+            <a:ext cx="8321040" cy="365760"/>
           </a:xfrm>
           <a:prstGeom prst="rect">
             <a:avLst/>
@@ -3536,6 +4220,46 @@
           <a:bodyPr wrap="square" lIns="0" tIns="0" rIns="0" bIns="0" rtlCol="0" anchor="t"/>
           <a:lstStyle/>
           <a:p>
+            <a:pPr marL="342900" indent="-342900">
+              <a:spcAft>
+                <a:spcPts val="800"/>
+              </a:spcAft>
+              <a:buSzPct val="100000"/>
+              <a:buChar char="•"/>
+            </a:pPr>
+            <a:r>
+              <a:rPr lang="en-US" sz="1500" dirty="0">
+                <a:solidFill>
+                  <a:schemeClr val="tx2"/>
+                </a:solidFill>
+              </a:rPr>
+              <a:t>The detected meal covers 98.6% of the annotated eating (F1 0.935)</a:t>
+            </a:r>
+            <a:endParaRPr lang="en-US" sz="1500" dirty="0"/>
+          </a:p>
+        </p:txBody>
+      </p:sp>
+      <p:sp>
+        <p:nvSpPr>
+          <p:cNvPr id="17" name="Text 14"/>
+          <p:cNvSpPr txBox="1"/>
+          <p:nvPr/>
+        </p:nvSpPr>
+        <p:spPr>
+          <a:xfrm>
+            <a:off x="411480" y="4251960"/>
+            <a:ext cx="7680960" cy="411480"/>
+          </a:xfrm>
+          <a:prstGeom prst="rect">
+            <a:avLst/>
+          </a:prstGeom>
+          <a:noFill/>
+          <a:ln/>
+        </p:spPr>
+        <p:txBody>
+          <a:bodyPr wrap="square" lIns="0" tIns="0" rIns="0" bIns="0" rtlCol="0" anchor="t"/>
+          <a:lstStyle/>
+          <a:p>
             <a:pPr indent="0" marL="0">
               <a:spcAft>
                 <a:spcPts val="800"/>
@@ -3543,14 +4267,14 @@
               <a:buNone/>
             </a:pPr>
             <a:r>
-              <a:rPr lang="en-US" sz="1300" dirty="0">
+              <a:rPr lang="en-US" sz="1100" dirty="0">
                 <a:solidFill>
                   <a:srgbClr val="7F7F7F"/>
                 </a:solidFill>
               </a:rPr>
-              <a:t>Participant was in the training set, so this shows the tool working, not generalisation.</a:t>
+              <a:t>Scripts: train_final_model.py and detect_eating.py. This participant was in the training set, so this demonstrates the tool, not performance on new people.</a:t>
             </a:r>
-            <a:endParaRPr lang="en-US" sz="1300" dirty="0"/>
+            <a:endParaRPr lang="en-US" sz="1100" dirty="0"/>
           </a:p>
         </p:txBody>
       </p:sp>
@@ -4033,7 +4757,7 @@
                   <a:schemeClr val="tx2"/>
                 </a:solidFill>
               </a:rPr>
-              <a:t>Questions: default threshold or false-alarm budget? Is food type recorded per session?</a:t>
+              <a:t>Question: is food type recorded for each session?</a:t>
             </a:r>
             <a:endParaRPr lang="en-US" sz="1800" dirty="0"/>
           </a:p>

</xml_diff>